<commit_message>
Ligeros cambios esteticos en el archivo base
</commit_message>
<xml_diff>
--- a/Modelo_PPT.pptx
+++ b/Modelo_PPT.pptx
@@ -9979,7 +9979,7 @@
           <a:p>
             <a:fld id="{42691DDE-BA6A-4F57-909C-98F49C72955F}" type="datetimeFigureOut">
               <a:rPr lang="en-GB" smtClean="0"/>
-              <a:t>12/08/2025</a:t>
+              <a:t>12/09/2025</a:t>
             </a:fld>
             <a:endParaRPr lang="en-GB" dirty="0"/>
           </a:p>
@@ -10160,7 +10160,7 @@
           <a:p>
             <a:fld id="{CBAAC5B1-F58D-4268-BB75-9856A9D794A6}" type="datetimeFigureOut">
               <a:rPr lang="en-GB" smtClean="0"/>
-              <a:t>12/08/2025</a:t>
+              <a:t>12/09/2025</a:t>
             </a:fld>
             <a:endParaRPr lang="en-GB" dirty="0"/>
           </a:p>
@@ -30781,8 +30781,8 @@
         </p:nvSpPr>
         <p:spPr bwMode="ltGray">
           <a:xfrm>
-            <a:off x="-19728" y="-9539"/>
-            <a:ext cx="12191999" cy="6858000"/>
+            <a:off x="-102107" y="-67205"/>
+            <a:ext cx="12417675" cy="7036415"/>
           </a:xfrm>
           <a:prstGeom prst="rect">
             <a:avLst/>
@@ -32283,10 +32283,10 @@
       </p:pic>
       <p:sp>
         <p:nvSpPr>
-          <p:cNvPr id="4" name="Marcador de número de diapositiva 3">
+          <p:cNvPr id="6" name="Marcador de número de diapositiva 5">
             <a:extLst>
               <a:ext uri="{FF2B5EF4-FFF2-40B4-BE49-F238E27FC236}">
-                <a16:creationId xmlns:a16="http://schemas.microsoft.com/office/drawing/2014/main" id="{FD706776-5317-6C68-1871-B336A16820E5}"/>
+                <a16:creationId xmlns:a16="http://schemas.microsoft.com/office/drawing/2014/main" id="{342463C2-5B70-CC05-EC92-A285419509A5}"/>
               </a:ext>
             </a:extLst>
           </p:cNvPr>
@@ -33994,10 +33994,10 @@
       </p:pic>
       <p:sp>
         <p:nvSpPr>
-          <p:cNvPr id="7" name="Marcador de número de diapositiva 6">
+          <p:cNvPr id="8" name="Marcador de número de diapositiva 7">
             <a:extLst>
               <a:ext uri="{FF2B5EF4-FFF2-40B4-BE49-F238E27FC236}">
-                <a16:creationId xmlns:a16="http://schemas.microsoft.com/office/drawing/2014/main" id="{56F1D3CF-BA89-D323-045E-C1E84FB33B39}"/>
+                <a16:creationId xmlns:a16="http://schemas.microsoft.com/office/drawing/2014/main" id="{DDD2B712-AF8E-40C8-14D6-1E3859EFEC9E}"/>
               </a:ext>
             </a:extLst>
           </p:cNvPr>
@@ -35827,10 +35827,10 @@
       </p:sp>
       <p:sp>
         <p:nvSpPr>
-          <p:cNvPr id="3" name="Marcador de número de diapositiva 2">
+          <p:cNvPr id="6" name="Marcador de número de diapositiva 5">
             <a:extLst>
               <a:ext uri="{FF2B5EF4-FFF2-40B4-BE49-F238E27FC236}">
-                <a16:creationId xmlns:a16="http://schemas.microsoft.com/office/drawing/2014/main" id="{77EB405E-B6FD-70EB-2D7B-CF9BC1ED20EA}"/>
+                <a16:creationId xmlns:a16="http://schemas.microsoft.com/office/drawing/2014/main" id="{8E53842B-0B7D-9B69-3F88-EE600F8B256D}"/>
               </a:ext>
             </a:extLst>
           </p:cNvPr>
@@ -37093,10 +37093,10 @@
       </p:sp>
       <p:sp>
         <p:nvSpPr>
-          <p:cNvPr id="4" name="Marcador de número de diapositiva 3">
+          <p:cNvPr id="5" name="Marcador de número de diapositiva 4">
             <a:extLst>
               <a:ext uri="{FF2B5EF4-FFF2-40B4-BE49-F238E27FC236}">
-                <a16:creationId xmlns:a16="http://schemas.microsoft.com/office/drawing/2014/main" id="{4F846ADD-D44F-177F-466E-72DD6F502B09}"/>
+                <a16:creationId xmlns:a16="http://schemas.microsoft.com/office/drawing/2014/main" id="{91B8C4E8-754E-28E7-07C1-5C1DC6A35C7B}"/>
               </a:ext>
             </a:extLst>
           </p:cNvPr>
@@ -38265,10 +38265,10 @@
       </p:sp>
       <p:sp>
         <p:nvSpPr>
-          <p:cNvPr id="15" name="Marcador de número de diapositiva 14">
+          <p:cNvPr id="14" name="Marcador de número de diapositiva 13">
             <a:extLst>
               <a:ext uri="{FF2B5EF4-FFF2-40B4-BE49-F238E27FC236}">
-                <a16:creationId xmlns:a16="http://schemas.microsoft.com/office/drawing/2014/main" id="{241DC279-8476-288C-2A13-1706715F3CA8}"/>
+                <a16:creationId xmlns:a16="http://schemas.microsoft.com/office/drawing/2014/main" id="{467434A5-42F8-E393-3B27-F643C2389AD0}"/>
               </a:ext>
             </a:extLst>
           </p:cNvPr>
@@ -40092,10 +40092,10 @@
       </p:sp>
       <p:sp>
         <p:nvSpPr>
-          <p:cNvPr id="17" name="Marcador de número de diapositiva 16">
+          <p:cNvPr id="8" name="Marcador de número de diapositiva 7">
             <a:extLst>
               <a:ext uri="{FF2B5EF4-FFF2-40B4-BE49-F238E27FC236}">
-                <a16:creationId xmlns:a16="http://schemas.microsoft.com/office/drawing/2014/main" id="{00F71A86-1C34-0B0C-6F61-0143BEB07DE7}"/>
+                <a16:creationId xmlns:a16="http://schemas.microsoft.com/office/drawing/2014/main" id="{ECF6C95A-C6EE-AEEA-261C-4CE605DC4020}"/>
               </a:ext>
             </a:extLst>
           </p:cNvPr>
@@ -41811,10 +41811,10 @@
       </p:pic>
       <p:sp>
         <p:nvSpPr>
-          <p:cNvPr id="7" name="Marcador de número de diapositiva 6">
+          <p:cNvPr id="8" name="Marcador de número de diapositiva 7">
             <a:extLst>
               <a:ext uri="{FF2B5EF4-FFF2-40B4-BE49-F238E27FC236}">
-                <a16:creationId xmlns:a16="http://schemas.microsoft.com/office/drawing/2014/main" id="{9F5A5982-C758-566F-12B4-54CB955A3B37}"/>
+                <a16:creationId xmlns:a16="http://schemas.microsoft.com/office/drawing/2014/main" id="{FC7D2DF7-343B-7EE7-CD7D-225B211D255C}"/>
               </a:ext>
             </a:extLst>
           </p:cNvPr>
@@ -42562,10 +42562,10 @@
       </p:sp>
       <p:sp>
         <p:nvSpPr>
-          <p:cNvPr id="3" name="Marcador de número de diapositiva 2">
+          <p:cNvPr id="7" name="Marcador de número de diapositiva 6">
             <a:extLst>
               <a:ext uri="{FF2B5EF4-FFF2-40B4-BE49-F238E27FC236}">
-                <a16:creationId xmlns:a16="http://schemas.microsoft.com/office/drawing/2014/main" id="{1C14B388-CF0E-65F6-F237-CA3D32DFF55D}"/>
+                <a16:creationId xmlns:a16="http://schemas.microsoft.com/office/drawing/2014/main" id="{0B4D638C-864A-C7C6-1205-573C0BD4CA0A}"/>
               </a:ext>
             </a:extLst>
           </p:cNvPr>
@@ -43766,10 +43766,10 @@
       </p:sp>
       <p:sp>
         <p:nvSpPr>
-          <p:cNvPr id="4" name="Marcador de número de diapositiva 3">
+          <p:cNvPr id="5" name="Marcador de número de diapositiva 4">
             <a:extLst>
               <a:ext uri="{FF2B5EF4-FFF2-40B4-BE49-F238E27FC236}">
-                <a16:creationId xmlns:a16="http://schemas.microsoft.com/office/drawing/2014/main" id="{A81BE8B3-EAC1-D5EE-287D-6AD363D5DB4F}"/>
+                <a16:creationId xmlns:a16="http://schemas.microsoft.com/office/drawing/2014/main" id="{B8C3E013-B05B-B009-FC37-7D01145A3564}"/>
               </a:ext>
             </a:extLst>
           </p:cNvPr>
@@ -44562,10 +44562,10 @@
       </p:pic>
       <p:sp>
         <p:nvSpPr>
-          <p:cNvPr id="3" name="Marcador de número de diapositiva 2">
+          <p:cNvPr id="7" name="Marcador de número de diapositiva 6">
             <a:extLst>
               <a:ext uri="{FF2B5EF4-FFF2-40B4-BE49-F238E27FC236}">
-                <a16:creationId xmlns:a16="http://schemas.microsoft.com/office/drawing/2014/main" id="{79AFD85F-E7CD-FA2F-69F6-81B0AD29793F}"/>
+                <a16:creationId xmlns:a16="http://schemas.microsoft.com/office/drawing/2014/main" id="{98AAD432-333F-EB72-FA6F-E15907B0A5E6}"/>
               </a:ext>
             </a:extLst>
           </p:cNvPr>
@@ -45996,10 +45996,10 @@
       </p:pic>
       <p:sp>
         <p:nvSpPr>
-          <p:cNvPr id="4" name="Marcador de número de diapositiva 3">
+          <p:cNvPr id="5" name="Marcador de número de diapositiva 4">
             <a:extLst>
               <a:ext uri="{FF2B5EF4-FFF2-40B4-BE49-F238E27FC236}">
-                <a16:creationId xmlns:a16="http://schemas.microsoft.com/office/drawing/2014/main" id="{E381DF99-FB7B-AAA1-5388-BE4B5431D605}"/>
+                <a16:creationId xmlns:a16="http://schemas.microsoft.com/office/drawing/2014/main" id="{008AC0D6-60ED-36D3-1ECA-1964F76D2F9F}"/>
               </a:ext>
             </a:extLst>
           </p:cNvPr>
@@ -47744,10 +47744,10 @@
       </p:pic>
       <p:sp>
         <p:nvSpPr>
-          <p:cNvPr id="7" name="Marcador de número de diapositiva 6">
+          <p:cNvPr id="8" name="Marcador de número de diapositiva 7">
             <a:extLst>
               <a:ext uri="{FF2B5EF4-FFF2-40B4-BE49-F238E27FC236}">
-                <a16:creationId xmlns:a16="http://schemas.microsoft.com/office/drawing/2014/main" id="{10F884BA-ABC9-BAFB-48B8-409982D1E9F2}"/>
+                <a16:creationId xmlns:a16="http://schemas.microsoft.com/office/drawing/2014/main" id="{AB10AB8D-E4B0-B5FD-9304-F3F9E800144A}"/>
               </a:ext>
             </a:extLst>
           </p:cNvPr>
@@ -48360,10 +48360,10 @@
       </p:sp>
       <p:sp>
         <p:nvSpPr>
-          <p:cNvPr id="3" name="Marcador de número de diapositiva 2">
+          <p:cNvPr id="7" name="Marcador de número de diapositiva 6">
             <a:extLst>
               <a:ext uri="{FF2B5EF4-FFF2-40B4-BE49-F238E27FC236}">
-                <a16:creationId xmlns:a16="http://schemas.microsoft.com/office/drawing/2014/main" id="{02C94957-8E84-B430-B310-BF59BF9450F3}"/>
+                <a16:creationId xmlns:a16="http://schemas.microsoft.com/office/drawing/2014/main" id="{D8FCF9F6-50D5-F95B-45A8-BDEB7C105056}"/>
               </a:ext>
             </a:extLst>
           </p:cNvPr>
@@ -49555,10 +49555,10 @@
       </p:sp>
       <p:sp>
         <p:nvSpPr>
-          <p:cNvPr id="4" name="Marcador de número de diapositiva 3">
+          <p:cNvPr id="5" name="Marcador de número de diapositiva 4">
             <a:extLst>
               <a:ext uri="{FF2B5EF4-FFF2-40B4-BE49-F238E27FC236}">
-                <a16:creationId xmlns:a16="http://schemas.microsoft.com/office/drawing/2014/main" id="{2B01C718-2350-3BCD-4FBA-2F26CBAA33AC}"/>
+                <a16:creationId xmlns:a16="http://schemas.microsoft.com/office/drawing/2014/main" id="{90D25E05-FFA4-11FB-42E3-FA788F865A57}"/>
               </a:ext>
             </a:extLst>
           </p:cNvPr>
@@ -50356,10 +50356,10 @@
       </p:pic>
       <p:sp>
         <p:nvSpPr>
-          <p:cNvPr id="3" name="Marcador de número de diapositiva 2">
+          <p:cNvPr id="8" name="Marcador de número de diapositiva 7">
             <a:extLst>
               <a:ext uri="{FF2B5EF4-FFF2-40B4-BE49-F238E27FC236}">
-                <a16:creationId xmlns:a16="http://schemas.microsoft.com/office/drawing/2014/main" id="{6E663804-18EE-13DA-2283-9C244CF28DF0}"/>
+                <a16:creationId xmlns:a16="http://schemas.microsoft.com/office/drawing/2014/main" id="{66B5DDFA-64B9-5B1B-2DAB-0A991AC26CD9}"/>
               </a:ext>
             </a:extLst>
           </p:cNvPr>
@@ -51546,14 +51546,12 @@
 </file>
 
 <file path=customXml/item1.xml><?xml version="1.0" encoding="utf-8"?>
-<p:properties xmlns:p="http://schemas.microsoft.com/office/2006/metadata/properties" xmlns:xsi="http://www.w3.org/2001/XMLSchema-instance" xmlns:pc="http://schemas.microsoft.com/office/infopath/2007/PartnerControls">
-  <documentManagement>
-    <lcf76f155ced4ddcb4097134ff3c332f xmlns="25f5c1ff-a3c5-44dd-9db4-c2b03110b401">
-      <Terms xmlns="http://schemas.microsoft.com/office/infopath/2007/PartnerControls"/>
-    </lcf76f155ced4ddcb4097134ff3c332f>
-    <TaxCatchAll xmlns="624e51cf-cfdd-4a8e-a169-534b8633fbcd" xsi:nil="true"/>
-  </documentManagement>
-</p:properties>
+<?mso-contentType ?>
+<FormTemplates xmlns="http://schemas.microsoft.com/sharepoint/v3/contenttype/forms">
+  <Display>DocumentLibraryForm</Display>
+  <Edit>DocumentLibraryForm</Edit>
+  <New>DocumentLibraryForm</New>
+</FormTemplates>
 </file>
 
 <file path=customXml/item2.xml><?xml version="1.0" encoding="utf-8"?>
@@ -51812,31 +51810,20 @@
 </file>
 
 <file path=customXml/item3.xml><?xml version="1.0" encoding="utf-8"?>
-<?mso-contentType ?>
-<FormTemplates xmlns="http://schemas.microsoft.com/sharepoint/v3/contenttype/forms">
-  <Display>DocumentLibraryForm</Display>
-  <Edit>DocumentLibraryForm</Edit>
-  <New>DocumentLibraryForm</New>
-</FormTemplates>
+<p:properties xmlns:p="http://schemas.microsoft.com/office/2006/metadata/properties" xmlns:xsi="http://www.w3.org/2001/XMLSchema-instance" xmlns:pc="http://schemas.microsoft.com/office/infopath/2007/PartnerControls">
+  <documentManagement>
+    <lcf76f155ced4ddcb4097134ff3c332f xmlns="25f5c1ff-a3c5-44dd-9db4-c2b03110b401">
+      <Terms xmlns="http://schemas.microsoft.com/office/infopath/2007/PartnerControls"/>
+    </lcf76f155ced4ddcb4097134ff3c332f>
+    <TaxCatchAll xmlns="624e51cf-cfdd-4a8e-a169-534b8633fbcd" xsi:nil="true"/>
+  </documentManagement>
+</p:properties>
 </file>
 
 <file path=customXml/itemProps1.xml><?xml version="1.0" encoding="utf-8"?>
-<ds:datastoreItem xmlns:ds="http://schemas.openxmlformats.org/officeDocument/2006/customXml" ds:itemID="{22193883-9DEF-4394-A746-8B0504B231C0}">
+<ds:datastoreItem xmlns:ds="http://schemas.openxmlformats.org/officeDocument/2006/customXml" ds:itemID="{BC375B81-FBF5-4924-A5E0-F0376D8E7D52}">
   <ds:schemaRefs>
-    <ds:schemaRef ds:uri="http://schemas.microsoft.com/office/2006/documentManagement/types"/>
-    <ds:schemaRef ds:uri="http://www.w3.org/XML/1998/namespace"/>
-    <ds:schemaRef ds:uri="77798f55-a83f-4680-b3b0-c27aeffd2bb7"/>
-    <ds:schemaRef ds:uri="http://purl.org/dc/dcmitype/"/>
-    <ds:schemaRef ds:uri="http://purl.org/dc/terms/"/>
-    <ds:schemaRef ds:uri="http://schemas.microsoft.com/office/infopath/2007/PartnerControls"/>
-    <ds:schemaRef ds:uri="http://schemas.openxmlformats.org/package/2006/metadata/core-properties"/>
-    <ds:schemaRef ds:uri="4b264726-908b-4d2c-b22b-6b55214f6ef7"/>
-    <ds:schemaRef ds:uri="http://schemas.microsoft.com/office/2006/metadata/properties"/>
-    <ds:schemaRef ds:uri="http://purl.org/dc/elements/1.1/"/>
-    <ds:schemaRef ds:uri="00e8e9ee-703c-4211-a2a5-4538efe6d9ef"/>
-    <ds:schemaRef ds:uri="02438bd5-34fd-489e-9e24-d77ec416fa1a"/>
-    <ds:schemaRef ds:uri="25f5c1ff-a3c5-44dd-9db4-c2b03110b401"/>
-    <ds:schemaRef ds:uri="624e51cf-cfdd-4a8e-a169-534b8633fbcd"/>
+    <ds:schemaRef ds:uri="http://schemas.microsoft.com/sharepoint/v3/contenttype/forms"/>
   </ds:schemaRefs>
 </ds:datastoreItem>
 </file>
@@ -51861,9 +51848,22 @@
 </file>
 
 <file path=customXml/itemProps3.xml><?xml version="1.0" encoding="utf-8"?>
-<ds:datastoreItem xmlns:ds="http://schemas.openxmlformats.org/officeDocument/2006/customXml" ds:itemID="{BC375B81-FBF5-4924-A5E0-F0376D8E7D52}">
+<ds:datastoreItem xmlns:ds="http://schemas.openxmlformats.org/officeDocument/2006/customXml" ds:itemID="{22193883-9DEF-4394-A746-8B0504B231C0}">
   <ds:schemaRefs>
-    <ds:schemaRef ds:uri="http://schemas.microsoft.com/sharepoint/v3/contenttype/forms"/>
+    <ds:schemaRef ds:uri="http://schemas.microsoft.com/office/2006/documentManagement/types"/>
+    <ds:schemaRef ds:uri="http://www.w3.org/XML/1998/namespace"/>
+    <ds:schemaRef ds:uri="77798f55-a83f-4680-b3b0-c27aeffd2bb7"/>
+    <ds:schemaRef ds:uri="http://purl.org/dc/dcmitype/"/>
+    <ds:schemaRef ds:uri="http://purl.org/dc/terms/"/>
+    <ds:schemaRef ds:uri="http://schemas.microsoft.com/office/infopath/2007/PartnerControls"/>
+    <ds:schemaRef ds:uri="http://schemas.openxmlformats.org/package/2006/metadata/core-properties"/>
+    <ds:schemaRef ds:uri="4b264726-908b-4d2c-b22b-6b55214f6ef7"/>
+    <ds:schemaRef ds:uri="http://schemas.microsoft.com/office/2006/metadata/properties"/>
+    <ds:schemaRef ds:uri="http://purl.org/dc/elements/1.1/"/>
+    <ds:schemaRef ds:uri="00e8e9ee-703c-4211-a2a5-4538efe6d9ef"/>
+    <ds:schemaRef ds:uri="02438bd5-34fd-489e-9e24-d77ec416fa1a"/>
+    <ds:schemaRef ds:uri="25f5c1ff-a3c5-44dd-9db4-c2b03110b401"/>
+    <ds:schemaRef ds:uri="624e51cf-cfdd-4a8e-a169-534b8633fbcd"/>
   </ds:schemaRefs>
 </ds:datastoreItem>
 </file>

</xml_diff>